<commit_message>
docs(code)+ppt: OCR 口径收口，PPT 指标与 README 对齐并新增 OCR 页
PPT（tools/make_ppt.py 是唯一数据源，重跑即再生成）
- 修正第 6 页指标口径：AFTER 由 6.67/33.3%/96.9% 改为 7.56/33.3%/93.0%，
  与 README、作品主页表格里的**同一行**对齐（此前三处打架，评委交叉核对即发现硬伤）；
  区间值只保留在 RANGE_NOTE 里，并注明"不挑最好的一次"
- 新增第 7 页「把最大的能力缺口补上：截图里的证据现在读得到了」：
  缺口是什么、怎么做的（逐页渲染 + deepseek-flash + 双档位 + 缓存）、守住的四条纪律
  （页码即坐标 / 读不出来写无法辨认 / 逐页失败隔离 / OCR 不参与最终裁定）
- 页脚总页数抽成 TOTAL_PAGES 常量（8 页），修掉"增页后页脚仍写 07"的隐患
- 第 8 页「下一步」补上 DOCX 内嵌图与读图准确率抽样评测

代码里已经过期的"不做 OCR"宣称（会变成自相矛盾的假话）
- parser.preview_caption 增加 ocr_on 开关：开了读图就必须换一套说法
- parser.render_pdf_pages 文档说明改为"本函数不做 OCR，要进证据链请走 ocr.py"，
  避免以后有人在这里偷偷加识别逻辑，把"给人看的"与"给模型读的"混成一份
- parser.inspect_text 的扫描件告警改为**建议开启多模态 OCR**，而不是陈述能力缺失
- app.show_page_preview 跟随本次是否真的开了 OCR 切换文案

一致性
- llm.call_json 的默认模型 deepseek-chat → deepseek-flash，
  与供应商表预设一致（默认值与界面预设不一致会让"测试连接"与真实评阅用不同模型）
- docs/模型接入设计.md 的共享额度示例改为官方口径：
  base_url 不带 /v1、模型 deepseek-flash，并说明 Cloud 的 Secrets 也会被读到

验证：232 passed / 7 skipped；verify_demo 3/3；smoke_ui_v4 通过
</commit_message>
<xml_diff>
--- a/AutoGrader-参赛答辩.pptx
+++ b/AutoGrader-参赛答辩.pptx
@@ -12,6 +12,7 @@
     <p:sldId id="260" r:id="rId11"/>
     <p:sldId id="261" r:id="rId12"/>
     <p:sldId id="262" r:id="rId13"/>
+    <p:sldId id="263" r:id="rId14"/>
   </p:sldIdLst>
   <p:sldSz cx="12191695" cy="6858000" type="screen4x3"/>
   <p:notesSz cx="6858000" cy="9144000"/>
@@ -3962,7 +3963,7 @@
                 <a:latin typeface="微软雅黑"/>
                 <a:ea typeface="微软雅黑"/>
               </a:rPr>
-              <a:t>02 / 07</a:t>
+              <a:t>02 / 08</a:t>
             </a:r>
           </a:p>
         </p:txBody>
@@ -5079,7 +5080,7 @@
                 <a:latin typeface="微软雅黑"/>
                 <a:ea typeface="微软雅黑"/>
               </a:rPr>
-              <a:t>03 / 07</a:t>
+              <a:t>03 / 08</a:t>
             </a:r>
           </a:p>
         </p:txBody>
@@ -6551,7 +6552,7 @@
                 <a:latin typeface="微软雅黑"/>
                 <a:ea typeface="微软雅黑"/>
               </a:rPr>
-              <a:t>04 / 07</a:t>
+              <a:t>04 / 08</a:t>
             </a:r>
           </a:p>
         </p:txBody>
@@ -7418,7 +7419,7 @@
                 <a:latin typeface="微软雅黑"/>
                 <a:ea typeface="微软雅黑"/>
               </a:rPr>
-              <a:t>05 / 07</a:t>
+              <a:t>05 / 08</a:t>
             </a:r>
           </a:p>
         </p:txBody>
@@ -9080,7 +9081,7 @@
                 <a:latin typeface="微软雅黑"/>
                 <a:ea typeface="微软雅黑"/>
               </a:rPr>
-              <a:t>06 / 07</a:t>
+              <a:t>06 / 08</a:t>
             </a:r>
           </a:p>
         </p:txBody>
@@ -9694,7 +9695,7 @@
                 <a:latin typeface="微软雅黑"/>
                 <a:ea typeface="微软雅黑"/>
               </a:rPr>
-              <a:t>缺陷修复后复测：MAE 6.67 分 / 误差≤5 占比 33.3% / 可溯源率 96.9%　——该修复发生在 gold 解封之后，是靠「系统性低估」这个信号查出来的，我们无法自证它没有沾到 gold 的光。 同一份代码两次完整评测：MAE 6.67~6.89，误差≤5 占比 33.3%~44.4%，可溯源率 96.9%~97.0% —— 波动就摆出来</a:t>
+              <a:t>缺陷修复后复测：MAE 7.56 分 / 误差≤5 占比 33.3% / 可溯源率 93.0%　——该修复发生在 gold 解封之后，是靠「系统性低估」这个信号查出来的，我们无法自证它没有沾到 gold 的光。 深度整改后同一份代码跑了两次完整评测：MAE 6.67~6.89，误差≤5 占比 33.3%~44.4%，可溯源率 96.9%~97.0% —— 波动就摆出来，不挑最好的一次</a:t>
             </a:r>
           </a:p>
         </p:txBody>
@@ -10062,7 +10063,7 @@
                 <a:latin typeface="微软雅黑"/>
                 <a:ea typeface="微软雅黑"/>
               </a:rPr>
-              <a:t>06 · AI 工具使用与下一步</a:t>
+              <a:t>06 · 多模态 OCR（新增能力）</a:t>
             </a:r>
           </a:p>
         </p:txBody>
@@ -10105,7 +10106,7 @@
                 <a:latin typeface="微软雅黑"/>
                 <a:ea typeface="微软雅黑"/>
               </a:rPr>
-              <a:t>AI 协作过程、团队与展望</a:t>
+              <a:t>把最大的能力缺口补上：截图里的证据现在读得到了</a:t>
             </a:r>
           </a:p>
         </p:txBody>
@@ -10237,7 +10238,7 @@
                 <a:latin typeface="微软雅黑"/>
                 <a:ea typeface="微软雅黑"/>
               </a:rPr>
-              <a:t>07 / 07</a:t>
+              <a:t>07 / 08</a:t>
             </a:r>
           </a:p>
         </p:txBody>
@@ -10251,7 +10252,7 @@
         <p:spPr>
           <a:xfrm>
             <a:off x="566928" y="1572768"/>
-            <a:ext cx="5486400" cy="2103120"/>
+            <a:ext cx="11064240" cy="1481328"/>
           </a:xfrm>
           <a:prstGeom prst="roundRect">
             <a:avLst>
@@ -10297,7 +10298,7 @@
         <p:spPr>
           <a:xfrm>
             <a:off x="566928" y="1572768"/>
-            <a:ext cx="50292" cy="2103120"/>
+            <a:ext cx="50292" cy="1481328"/>
           </a:xfrm>
           <a:prstGeom prst="roundRect">
             <a:avLst>
@@ -10343,7 +10344,7 @@
         <p:spPr>
           <a:xfrm>
             <a:off x="822960" y="1737360"/>
-            <a:ext cx="5029200" cy="310896"/>
+            <a:ext cx="10607040" cy="310896"/>
           </a:xfrm>
           <a:prstGeom prst="rect">
             <a:avLst/>
@@ -10372,7 +10373,7 @@
                 <a:latin typeface="微软雅黑"/>
                 <a:ea typeface="微软雅黑"/>
               </a:rPr>
-              <a:t>AI 帮我们抓到的两个真实缺陷</a:t>
+              <a:t>缺口：计算机实验报告最关键的证据是截图</a:t>
             </a:r>
           </a:p>
         </p:txBody>
@@ -10386,7 +10387,7 @@
         <p:spPr>
           <a:xfrm>
             <a:off x="822960" y="2066543"/>
-            <a:ext cx="5029200" cy="1444751"/>
+            <a:ext cx="10607040" cy="822960"/>
           </a:xfrm>
           <a:prstGeom prst="rect">
             <a:avLst/>
@@ -10415,47 +10416,7 @@
                 <a:latin typeface="微软雅黑"/>
                 <a:ea typeface="微软雅黑"/>
               </a:rPr>
-              <a:t>① 上下文丢失：模型只看到报告 7%~11% 内容（MAE 31.67 → 20.44）</a:t>
-            </a:r>
-          </a:p>
-          <a:p>
-            <a:pPr algn="l">
-              <a:lnSpc>
-                <a:spcPct val="125000"/>
-              </a:lnSpc>
-              <a:spcAft>
-                <a:spcPts val="600"/>
-              </a:spcAft>
-            </a:pPr>
-            <a:r>
-              <a:rPr sz="1200" b="0">
-                <a:solidFill>
-                  <a:srgbClr val="1F2937"/>
-                </a:solidFill>
-                <a:latin typeface="微软雅黑"/>
-                <a:ea typeface="微软雅黑"/>
-              </a:rPr>
-              <a:t>② 反馈生成失败：异常被 except 吞掉，查不到原因；最后靠另一项功能测试才炸出真凶——输出的 JSON 含未转义引号</a:t>
-            </a:r>
-          </a:p>
-          <a:p>
-            <a:pPr algn="l">
-              <a:lnSpc>
-                <a:spcPct val="125000"/>
-              </a:lnSpc>
-              <a:spcAft>
-                <a:spcPts val="600"/>
-              </a:spcAft>
-            </a:pPr>
-            <a:r>
-              <a:rPr sz="1200" b="0">
-                <a:solidFill>
-                  <a:srgbClr val="1F2937"/>
-                </a:solidFill>
-                <a:latin typeface="微软雅黑"/>
-                <a:ea typeface="微软雅黑"/>
-              </a:rPr>
-              <a:t>两篇排查记录都在仓库 docs/ 下，是当时写下的，不是事后美化</a:t>
+              <a:t>运行结果、报错信息、结果表格大量以截图形式存在。纯文本抽取只能拿到「运行结果示例」这行标题，正文是空的 —— 于是「结果与数据」这类评分点无据可依，一整类报告被系统性判低。此前我们把它写成「已知局限」，现在它被修掉了。</a:t>
             </a:r>
           </a:p>
         </p:txBody>
@@ -10468,8 +10429,8 @@
         </p:nvSpPr>
         <p:spPr>
           <a:xfrm>
-            <a:off x="6236208" y="1572768"/>
-            <a:ext cx="5394960" cy="2103120"/>
+            <a:off x="566928" y="3200400"/>
+            <a:ext cx="5486400" cy="2026158"/>
           </a:xfrm>
           <a:prstGeom prst="roundRect">
             <a:avLst>
@@ -10514,8 +10475,565 @@
         </p:nvSpPr>
         <p:spPr>
           <a:xfrm>
-            <a:off x="6236208" y="1572768"/>
-            <a:ext cx="50292" cy="2103120"/>
+            <a:off x="566928" y="3200400"/>
+            <a:ext cx="50292" cy="2026158"/>
+          </a:xfrm>
+          <a:prstGeom prst="roundRect">
+            <a:avLst>
+              <a:gd name="adj" fmla="val 50000"/>
+            </a:avLst>
+          </a:prstGeom>
+          <a:solidFill>
+            <a:srgbClr val="B45309"/>
+          </a:solidFill>
+          <a:ln>
+            <a:noFill/>
+          </a:ln>
+          <a:effectLst/>
+        </p:spPr>
+        <p:style>
+          <a:lnRef idx="1">
+            <a:schemeClr val="accent1"/>
+          </a:lnRef>
+          <a:fillRef idx="3">
+            <a:schemeClr val="accent1"/>
+          </a:fillRef>
+          <a:effectRef idx="2">
+            <a:schemeClr val="accent1"/>
+          </a:effectRef>
+          <a:fontRef idx="minor">
+            <a:schemeClr val="lt1"/>
+          </a:fontRef>
+        </p:style>
+        <p:txBody>
+          <a:bodyPr rtlCol="0" anchor="ctr" wrap="square"/>
+          <a:lstStyle/>
+          <a:p>
+            <a:pPr algn="ctr"/>
+          </a:p>
+        </p:txBody>
+      </p:sp>
+      <p:sp>
+        <p:nvSpPr>
+          <p:cNvPr id="13" name="TextBox 12"/>
+          <p:cNvSpPr txBox="1"/>
+          <p:nvPr/>
+        </p:nvSpPr>
+        <p:spPr>
+          <a:xfrm>
+            <a:off x="822960" y="3364992"/>
+            <a:ext cx="5029200" cy="310896"/>
+          </a:xfrm>
+          <a:prstGeom prst="rect">
+            <a:avLst/>
+          </a:prstGeom>
+          <a:noFill/>
+        </p:spPr>
+        <p:txBody>
+          <a:bodyPr wrap="square" anchor="t" lIns="0" rIns="0" tIns="0" bIns="0">
+            <a:spAutoFit/>
+          </a:bodyPr>
+          <a:lstStyle/>
+          <a:p>
+            <a:pPr algn="l">
+              <a:lnSpc>
+                <a:spcPct val="125000"/>
+              </a:lnSpc>
+              <a:spcAft>
+                <a:spcPts val="800"/>
+              </a:spcAft>
+            </a:pPr>
+            <a:r>
+              <a:rPr sz="1500" b="1">
+                <a:solidFill>
+                  <a:srgbClr val="B45309"/>
+                </a:solidFill>
+                <a:latin typeface="微软雅黑"/>
+                <a:ea typeface="微软雅黑"/>
+              </a:rPr>
+              <a:t>怎么做的</a:t>
+            </a:r>
+          </a:p>
+        </p:txBody>
+      </p:sp>
+      <p:sp>
+        <p:nvSpPr>
+          <p:cNvPr id="14" name="TextBox 13"/>
+          <p:cNvSpPr txBox="1"/>
+          <p:nvPr/>
+        </p:nvSpPr>
+        <p:spPr>
+          <a:xfrm>
+            <a:off x="822960" y="3694176"/>
+            <a:ext cx="5029200" cy="1367790"/>
+          </a:xfrm>
+          <a:prstGeom prst="rect">
+            <a:avLst/>
+          </a:prstGeom>
+          <a:noFill/>
+        </p:spPr>
+        <p:txBody>
+          <a:bodyPr wrap="square" anchor="t" lIns="0" rIns="0" tIns="0" bIns="0">
+            <a:spAutoFit/>
+          </a:bodyPr>
+          <a:lstStyle/>
+          <a:p>
+            <a:pPr algn="l">
+              <a:lnSpc>
+                <a:spcPct val="125000"/>
+              </a:lnSpc>
+              <a:spcAft>
+                <a:spcPts val="600"/>
+              </a:spcAft>
+            </a:pPr>
+            <a:r>
+              <a:rPr sz="1150" b="0">
+                <a:solidFill>
+                  <a:srgbClr val="1F2937"/>
+                </a:solidFill>
+                <a:latin typeface="微软雅黑"/>
+                <a:ea typeface="微软雅黑"/>
+              </a:rPr>
+              <a:t>逐页渲染成图片，交给 deepseek-flash（DeepSeek-V4.1-Flash，官方标注 Vision）转录</a:t>
+            </a:r>
+          </a:p>
+          <a:p>
+            <a:pPr algn="l">
+              <a:lnSpc>
+                <a:spcPct val="125000"/>
+              </a:lnSpc>
+              <a:spcAft>
+                <a:spcPts val="600"/>
+              </a:spcAft>
+            </a:pPr>
+            <a:r>
+              <a:rPr sz="1150" b="0">
+                <a:solidFill>
+                  <a:srgbClr val="1F2937"/>
+                </a:solidFill>
+                <a:latin typeface="微软雅黑"/>
+                <a:ea typeface="微软雅黑"/>
+              </a:rPr>
+              <a:t>两种档位：正文没有代码/输出 → 全量转录；正文已有代码 → 只描述图片，避免重复计分、成本更低</a:t>
+            </a:r>
+          </a:p>
+          <a:p>
+            <a:pPr algn="l">
+              <a:lnSpc>
+                <a:spcPct val="125000"/>
+              </a:lnSpc>
+              <a:spcAft>
+                <a:spcPts val="600"/>
+              </a:spcAft>
+            </a:pPr>
+            <a:r>
+              <a:rPr sz="1150" b="0">
+                <a:solidFill>
+                  <a:srgbClr val="1F2937"/>
+                </a:solidFill>
+                <a:latin typeface="微软雅黑"/>
+                <a:ea typeface="微软雅黑"/>
+              </a:rPr>
+              <a:t>结果按「文件哈希 + DPI + 模型 + 提示词版本」缓存，重复评阅不重复计费</a:t>
+            </a:r>
+          </a:p>
+        </p:txBody>
+      </p:sp>
+      <p:sp>
+        <p:nvSpPr>
+          <p:cNvPr id="15" name="Rounded Rectangle 14"/>
+          <p:cNvSpPr/>
+          <p:nvPr/>
+        </p:nvSpPr>
+        <p:spPr>
+          <a:xfrm>
+            <a:off x="6236208" y="3200400"/>
+            <a:ext cx="5394960" cy="2102358"/>
+          </a:xfrm>
+          <a:prstGeom prst="roundRect">
+            <a:avLst>
+              <a:gd name="adj" fmla="val 8000"/>
+            </a:avLst>
+          </a:prstGeom>
+          <a:solidFill>
+            <a:srgbClr val="F3F4F6"/>
+          </a:solidFill>
+          <a:ln>
+            <a:noFill/>
+          </a:ln>
+          <a:effectLst/>
+        </p:spPr>
+        <p:style>
+          <a:lnRef idx="1">
+            <a:schemeClr val="accent1"/>
+          </a:lnRef>
+          <a:fillRef idx="3">
+            <a:schemeClr val="accent1"/>
+          </a:fillRef>
+          <a:effectRef idx="2">
+            <a:schemeClr val="accent1"/>
+          </a:effectRef>
+          <a:fontRef idx="minor">
+            <a:schemeClr val="lt1"/>
+          </a:fontRef>
+        </p:style>
+        <p:txBody>
+          <a:bodyPr rtlCol="0" anchor="ctr" wrap="square"/>
+          <a:lstStyle/>
+          <a:p>
+            <a:pPr algn="ctr"/>
+          </a:p>
+        </p:txBody>
+      </p:sp>
+      <p:sp>
+        <p:nvSpPr>
+          <p:cNvPr id="16" name="Rounded Rectangle 15"/>
+          <p:cNvSpPr/>
+          <p:nvPr/>
+        </p:nvSpPr>
+        <p:spPr>
+          <a:xfrm>
+            <a:off x="6236208" y="3200400"/>
+            <a:ext cx="50292" cy="2102358"/>
+          </a:xfrm>
+          <a:prstGeom prst="roundRect">
+            <a:avLst>
+              <a:gd name="adj" fmla="val 50000"/>
+            </a:avLst>
+          </a:prstGeom>
+          <a:solidFill>
+            <a:srgbClr val="B45309"/>
+          </a:solidFill>
+          <a:ln>
+            <a:noFill/>
+          </a:ln>
+          <a:effectLst/>
+        </p:spPr>
+        <p:style>
+          <a:lnRef idx="1">
+            <a:schemeClr val="accent1"/>
+          </a:lnRef>
+          <a:fillRef idx="3">
+            <a:schemeClr val="accent1"/>
+          </a:fillRef>
+          <a:effectRef idx="2">
+            <a:schemeClr val="accent1"/>
+          </a:effectRef>
+          <a:fontRef idx="minor">
+            <a:schemeClr val="lt1"/>
+          </a:fontRef>
+        </p:style>
+        <p:txBody>
+          <a:bodyPr rtlCol="0" anchor="ctr" wrap="square"/>
+          <a:lstStyle/>
+          <a:p>
+            <a:pPr algn="ctr"/>
+          </a:p>
+        </p:txBody>
+      </p:sp>
+      <p:sp>
+        <p:nvSpPr>
+          <p:cNvPr id="17" name="TextBox 16"/>
+          <p:cNvSpPr txBox="1"/>
+          <p:nvPr/>
+        </p:nvSpPr>
+        <p:spPr>
+          <a:xfrm>
+            <a:off x="6492240" y="3364992"/>
+            <a:ext cx="4937760" cy="310896"/>
+          </a:xfrm>
+          <a:prstGeom prst="rect">
+            <a:avLst/>
+          </a:prstGeom>
+          <a:noFill/>
+        </p:spPr>
+        <p:txBody>
+          <a:bodyPr wrap="square" anchor="t" lIns="0" rIns="0" tIns="0" bIns="0">
+            <a:spAutoFit/>
+          </a:bodyPr>
+          <a:lstStyle/>
+          <a:p>
+            <a:pPr algn="l">
+              <a:lnSpc>
+                <a:spcPct val="125000"/>
+              </a:lnSpc>
+              <a:spcAft>
+                <a:spcPts val="800"/>
+              </a:spcAft>
+            </a:pPr>
+            <a:r>
+              <a:rPr sz="1500" b="1">
+                <a:solidFill>
+                  <a:srgbClr val="B45309"/>
+                </a:solidFill>
+                <a:latin typeface="微软雅黑"/>
+                <a:ea typeface="微软雅黑"/>
+              </a:rPr>
+              <a:t>守住的四条纪律</a:t>
+            </a:r>
+          </a:p>
+        </p:txBody>
+      </p:sp>
+      <p:sp>
+        <p:nvSpPr>
+          <p:cNvPr id="18" name="TextBox 17"/>
+          <p:cNvSpPr txBox="1"/>
+          <p:nvPr/>
+        </p:nvSpPr>
+        <p:spPr>
+          <a:xfrm>
+            <a:off x="6492240" y="3694176"/>
+            <a:ext cx="4937760" cy="1443990"/>
+          </a:xfrm>
+          <a:prstGeom prst="rect">
+            <a:avLst/>
+          </a:prstGeom>
+          <a:noFill/>
+        </p:spPr>
+        <p:txBody>
+          <a:bodyPr wrap="square" anchor="t" lIns="0" rIns="0" tIns="0" bIns="0">
+            <a:spAutoFit/>
+          </a:bodyPr>
+          <a:lstStyle/>
+          <a:p>
+            <a:pPr algn="l">
+              <a:lnSpc>
+                <a:spcPct val="125000"/>
+              </a:lnSpc>
+              <a:spcAft>
+                <a:spcPts val="600"/>
+              </a:spcAft>
+            </a:pPr>
+            <a:r>
+              <a:rPr sz="1150" b="0">
+                <a:solidFill>
+                  <a:srgbClr val="1F2937"/>
+                </a:solidFill>
+                <a:latin typeface="微软雅黑"/>
+                <a:ea typeface="微软雅黑"/>
+              </a:rPr>
+              <a:t>页码即坐标：每页转录带「第 N 页」标题，证据可以精确指到某一页</a:t>
+            </a:r>
+          </a:p>
+          <a:p>
+            <a:pPr algn="l">
+              <a:lnSpc>
+                <a:spcPct val="125000"/>
+              </a:lnSpc>
+              <a:spcAft>
+                <a:spcPts val="600"/>
+              </a:spcAft>
+            </a:pPr>
+            <a:r>
+              <a:rPr sz="1150" b="0">
+                <a:solidFill>
+                  <a:srgbClr val="1F2937"/>
+                </a:solidFill>
+                <a:latin typeface="微软雅黑"/>
+                <a:ea typeface="微软雅黑"/>
+              </a:rPr>
+              <a:t>读不出来就写「无法辨认」——「看不出内容」不等于「没有内容」</a:t>
+            </a:r>
+          </a:p>
+          <a:p>
+            <a:pPr algn="l">
+              <a:lnSpc>
+                <a:spcPct val="125000"/>
+              </a:lnSpc>
+              <a:spcAft>
+                <a:spcPts val="600"/>
+              </a:spcAft>
+            </a:pPr>
+            <a:r>
+              <a:rPr sz="1150" b="0">
+                <a:solidFill>
+                  <a:srgbClr val="1F2937"/>
+                </a:solidFill>
+                <a:latin typeface="微软雅黑"/>
+                <a:ea typeface="微软雅黑"/>
+              </a:rPr>
+              <a:t>逐页失败隔离：第 3 页读不出来不影响其余页，OCR 整体失败只降级、不阻断评阅</a:t>
+            </a:r>
+          </a:p>
+          <a:p>
+            <a:pPr algn="l">
+              <a:lnSpc>
+                <a:spcPct val="125000"/>
+              </a:lnSpc>
+              <a:spcAft>
+                <a:spcPts val="600"/>
+              </a:spcAft>
+            </a:pPr>
+            <a:r>
+              <a:rPr sz="1150" b="0">
+                <a:solidFill>
+                  <a:srgbClr val="1F2937"/>
+                </a:solidFill>
+                <a:latin typeface="微软雅黑"/>
+                <a:ea typeface="微软雅黑"/>
+              </a:rPr>
+              <a:t>OCR 只影响「模型能看到什么」，不参与最终裁定，界面同时给原始版面对照</a:t>
+            </a:r>
+          </a:p>
+        </p:txBody>
+      </p:sp>
+      <p:sp>
+        <p:nvSpPr>
+          <p:cNvPr id="19" name="TextBox 18"/>
+          <p:cNvSpPr txBox="1"/>
+          <p:nvPr/>
+        </p:nvSpPr>
+        <p:spPr>
+          <a:xfrm>
+            <a:off x="566928" y="5175504"/>
+            <a:ext cx="11064240" cy="640080"/>
+          </a:xfrm>
+          <a:prstGeom prst="rect">
+            <a:avLst/>
+          </a:prstGeom>
+          <a:noFill/>
+        </p:spPr>
+        <p:txBody>
+          <a:bodyPr wrap="square" anchor="t" lIns="0" rIns="0" tIns="0" bIns="0">
+            <a:spAutoFit/>
+          </a:bodyPr>
+          <a:lstStyle/>
+          <a:p>
+            <a:pPr algn="l">
+              <a:lnSpc>
+                <a:spcPct val="125000"/>
+              </a:lnSpc>
+              <a:spcAft>
+                <a:spcPts val="800"/>
+              </a:spcAft>
+            </a:pPr>
+            <a:r>
+              <a:rPr sz="1250" b="0">
+                <a:solidFill>
+                  <a:srgbClr val="6B7280"/>
+                </a:solidFill>
+                <a:latin typeface="微软雅黑"/>
+                <a:ea typeface="微软雅黑"/>
+              </a:rPr>
+              <a:t>一句话：这一页不是「我们打算做 OCR」，而是「OCR 已经跑通、有测试、可复现」。证据仍然必须通过代码的原文逐字校验 —— 读出来的内容不被特殊对待。</a:t>
+            </a:r>
+          </a:p>
+        </p:txBody>
+      </p:sp>
+    </p:spTree>
+  </p:cSld>
+  <p:clrMapOvr>
+    <a:masterClrMapping/>
+  </p:clrMapOvr>
+</p:sld>
+</file>
+
+<file path=ppt/slides/slide8.xml><?xml version="1.0" encoding="utf-8"?>
+<p:sld xmlns:a="http://schemas.openxmlformats.org/drawingml/2006/main" xmlns:p="http://schemas.openxmlformats.org/presentationml/2006/main" xmlns:r="http://schemas.openxmlformats.org/officeDocument/2006/relationships">
+  <p:cSld>
+    <p:spTree>
+      <p:nvGrpSpPr>
+        <p:cNvPr id="1" name=""/>
+        <p:cNvGrpSpPr/>
+        <p:nvPr/>
+      </p:nvGrpSpPr>
+      <p:grpSpPr/>
+      <p:sp>
+        <p:nvSpPr>
+          <p:cNvPr id="2" name="TextBox 1"/>
+          <p:cNvSpPr txBox="1"/>
+          <p:nvPr/>
+        </p:nvSpPr>
+        <p:spPr>
+          <a:xfrm>
+            <a:off x="566928" y="384048"/>
+            <a:ext cx="10515600" cy="274320"/>
+          </a:xfrm>
+          <a:prstGeom prst="rect">
+            <a:avLst/>
+          </a:prstGeom>
+          <a:noFill/>
+        </p:spPr>
+        <p:txBody>
+          <a:bodyPr wrap="square" anchor="t" lIns="0" rIns="0" tIns="0" bIns="0">
+            <a:spAutoFit/>
+          </a:bodyPr>
+          <a:lstStyle/>
+          <a:p>
+            <a:pPr algn="l">
+              <a:lnSpc>
+                <a:spcPct val="125000"/>
+              </a:lnSpc>
+              <a:spcAft>
+                <a:spcPts val="800"/>
+              </a:spcAft>
+            </a:pPr>
+            <a:r>
+              <a:rPr sz="1100" b="1">
+                <a:solidFill>
+                  <a:srgbClr val="0F766E"/>
+                </a:solidFill>
+                <a:latin typeface="微软雅黑"/>
+                <a:ea typeface="微软雅黑"/>
+              </a:rPr>
+              <a:t>07 · AI 工具使用与下一步</a:t>
+            </a:r>
+          </a:p>
+        </p:txBody>
+      </p:sp>
+      <p:sp>
+        <p:nvSpPr>
+          <p:cNvPr id="3" name="TextBox 2"/>
+          <p:cNvSpPr txBox="1"/>
+          <p:nvPr/>
+        </p:nvSpPr>
+        <p:spPr>
+          <a:xfrm>
+            <a:off x="566928" y="676656"/>
+            <a:ext cx="10881360" cy="658368"/>
+          </a:xfrm>
+          <a:prstGeom prst="rect">
+            <a:avLst/>
+          </a:prstGeom>
+          <a:noFill/>
+        </p:spPr>
+        <p:txBody>
+          <a:bodyPr wrap="square" anchor="t" lIns="0" rIns="0" tIns="0" bIns="0">
+            <a:spAutoFit/>
+          </a:bodyPr>
+          <a:lstStyle/>
+          <a:p>
+            <a:pPr algn="l">
+              <a:lnSpc>
+                <a:spcPct val="125000"/>
+              </a:lnSpc>
+              <a:spcAft>
+                <a:spcPts val="800"/>
+              </a:spcAft>
+            </a:pPr>
+            <a:r>
+              <a:rPr sz="2700" b="1">
+                <a:solidFill>
+                  <a:srgbClr val="1F2937"/>
+                </a:solidFill>
+                <a:latin typeface="微软雅黑"/>
+                <a:ea typeface="微软雅黑"/>
+              </a:rPr>
+              <a:t>AI 协作过程、团队与展望</a:t>
+            </a:r>
+          </a:p>
+        </p:txBody>
+      </p:sp>
+      <p:sp>
+        <p:nvSpPr>
+          <p:cNvPr id="4" name="Rounded Rectangle 3"/>
+          <p:cNvSpPr/>
+          <p:nvPr/>
+        </p:nvSpPr>
+        <p:spPr>
+          <a:xfrm>
+            <a:off x="566928" y="1389888"/>
+            <a:ext cx="960120" cy="50292"/>
           </a:xfrm>
           <a:prstGeom prst="roundRect">
             <a:avLst>
@@ -10554,14 +11072,14 @@
       </p:sp>
       <p:sp>
         <p:nvSpPr>
-          <p:cNvPr id="13" name="TextBox 12"/>
+          <p:cNvPr id="5" name="TextBox 4"/>
           <p:cNvSpPr txBox="1"/>
           <p:nvPr/>
         </p:nvSpPr>
         <p:spPr>
           <a:xfrm>
-            <a:off x="6492240" y="1737360"/>
-            <a:ext cx="4937760" cy="310896"/>
+            <a:off x="566928" y="6327648"/>
+            <a:ext cx="7315200" cy="256032"/>
           </a:xfrm>
           <a:prstGeom prst="rect">
             <a:avLst/>
@@ -10583,28 +11101,28 @@
               </a:spcAft>
             </a:pPr>
             <a:r>
-              <a:rPr sz="1500" b="1">
-                <a:solidFill>
-                  <a:srgbClr val="1F2937"/>
-                </a:solidFill>
-                <a:latin typeface="微软雅黑"/>
-                <a:ea typeface="微软雅黑"/>
-              </a:rPr>
-              <a:t>AI 在工程里的位置</a:t>
-            </a:r>
-          </a:p>
-        </p:txBody>
-      </p:sp>
-      <p:sp>
-        <p:nvSpPr>
-          <p:cNvPr id="14" name="TextBox 13"/>
+              <a:rPr sz="1000" b="0">
+                <a:solidFill>
+                  <a:srgbClr val="6B7280"/>
+                </a:solidFill>
+                <a:latin typeface="微软雅黑"/>
+                <a:ea typeface="微软雅黑"/>
+              </a:rPr>
+              <a:t>AutoGrader · RAG-E 四阶判定链 · 每条判定都可溯源到报告原文</a:t>
+            </a:r>
+          </a:p>
+        </p:txBody>
+      </p:sp>
+      <p:sp>
+        <p:nvSpPr>
+          <p:cNvPr id="6" name="TextBox 5"/>
           <p:cNvSpPr txBox="1"/>
           <p:nvPr/>
         </p:nvSpPr>
         <p:spPr>
           <a:xfrm>
-            <a:off x="6492240" y="2066543"/>
-            <a:ext cx="4937760" cy="1444751"/>
+            <a:off x="10241280" y="6327648"/>
+            <a:ext cx="1371600" cy="256032"/>
           </a:xfrm>
           <a:prstGeom prst="rect">
             <a:avLst/>
@@ -10617,77 +11135,37 @@
           </a:bodyPr>
           <a:lstStyle/>
           <a:p>
-            <a:pPr algn="l">
-              <a:lnSpc>
-                <a:spcPct val="125000"/>
-              </a:lnSpc>
-              <a:spcAft>
-                <a:spcPts val="600"/>
-              </a:spcAft>
-            </a:pPr>
-            <a:r>
-              <a:rPr sz="1200" b="0">
-                <a:solidFill>
-                  <a:srgbClr val="1F2937"/>
-                </a:solidFill>
-                <a:latin typeface="微软雅黑"/>
-                <a:ea typeface="微软雅黑"/>
-              </a:rPr>
-              <a:t>代码骨架、prompt 初稿、界面实现由 AI 协作产出</a:t>
-            </a:r>
-          </a:p>
-          <a:p>
-            <a:pPr algn="l">
-              <a:lnSpc>
-                <a:spcPct val="125000"/>
-              </a:lnSpc>
-              <a:spcAft>
-                <a:spcPts val="600"/>
-              </a:spcAft>
-            </a:pPr>
-            <a:r>
-              <a:rPr sz="1200" b="0">
-                <a:solidFill>
-                  <a:srgbClr val="1F2937"/>
-                </a:solidFill>
-                <a:latin typeface="微软雅黑"/>
-                <a:ea typeface="微软雅黑"/>
-              </a:rPr>
-              <a:t>判定规则、评分点定义、gold set 打分由人完成</a:t>
-            </a:r>
-          </a:p>
-          <a:p>
-            <a:pPr algn="l">
-              <a:lnSpc>
-                <a:spcPct val="125000"/>
-              </a:lnSpc>
-              <a:spcAft>
-                <a:spcPts val="600"/>
-              </a:spcAft>
-            </a:pPr>
-            <a:r>
-              <a:rPr sz="1200" b="0">
-                <a:solidFill>
-                  <a:srgbClr val="1F2937"/>
-                </a:solidFill>
-                <a:latin typeface="微软雅黑"/>
-                <a:ea typeface="微软雅黑"/>
-              </a:rPr>
-              <a:t>「不许吞异常」「不许放宽匹配规则」是我们给自己立的规矩</a:t>
-            </a:r>
-          </a:p>
-        </p:txBody>
-      </p:sp>
-      <p:sp>
-        <p:nvSpPr>
-          <p:cNvPr id="15" name="Rounded Rectangle 14"/>
+            <a:pPr algn="r">
+              <a:lnSpc>
+                <a:spcPct val="125000"/>
+              </a:lnSpc>
+              <a:spcAft>
+                <a:spcPts val="800"/>
+              </a:spcAft>
+            </a:pPr>
+            <a:r>
+              <a:rPr sz="1000" b="0">
+                <a:solidFill>
+                  <a:srgbClr val="6B7280"/>
+                </a:solidFill>
+                <a:latin typeface="微软雅黑"/>
+                <a:ea typeface="微软雅黑"/>
+              </a:rPr>
+              <a:t>08 / 08</a:t>
+            </a:r>
+          </a:p>
+        </p:txBody>
+      </p:sp>
+      <p:sp>
+        <p:nvSpPr>
+          <p:cNvPr id="7" name="Rounded Rectangle 6"/>
           <p:cNvSpPr/>
           <p:nvPr/>
         </p:nvSpPr>
         <p:spPr>
           <a:xfrm>
-            <a:off x="566928" y="3822191"/>
-            <a:ext cx="5486400" cy="1795018"/>
+            <a:off x="566928" y="1572768"/>
+            <a:ext cx="5486400" cy="2103120"/>
           </a:xfrm>
           <a:prstGeom prst="roundRect">
             <a:avLst>
@@ -10726,14 +11204,232 @@
       </p:sp>
       <p:sp>
         <p:nvSpPr>
-          <p:cNvPr id="16" name="Rounded Rectangle 15"/>
+          <p:cNvPr id="8" name="Rounded Rectangle 7"/>
           <p:cNvSpPr/>
           <p:nvPr/>
         </p:nvSpPr>
         <p:spPr>
           <a:xfrm>
-            <a:off x="566928" y="3822191"/>
-            <a:ext cx="50292" cy="1795018"/>
+            <a:off x="566928" y="1572768"/>
+            <a:ext cx="50292" cy="2103120"/>
+          </a:xfrm>
+          <a:prstGeom prst="roundRect">
+            <a:avLst>
+              <a:gd name="adj" fmla="val 50000"/>
+            </a:avLst>
+          </a:prstGeom>
+          <a:solidFill>
+            <a:srgbClr val="B45309"/>
+          </a:solidFill>
+          <a:ln>
+            <a:noFill/>
+          </a:ln>
+          <a:effectLst/>
+        </p:spPr>
+        <p:style>
+          <a:lnRef idx="1">
+            <a:schemeClr val="accent1"/>
+          </a:lnRef>
+          <a:fillRef idx="3">
+            <a:schemeClr val="accent1"/>
+          </a:fillRef>
+          <a:effectRef idx="2">
+            <a:schemeClr val="accent1"/>
+          </a:effectRef>
+          <a:fontRef idx="minor">
+            <a:schemeClr val="lt1"/>
+          </a:fontRef>
+        </p:style>
+        <p:txBody>
+          <a:bodyPr rtlCol="0" anchor="ctr" wrap="square"/>
+          <a:lstStyle/>
+          <a:p>
+            <a:pPr algn="ctr"/>
+          </a:p>
+        </p:txBody>
+      </p:sp>
+      <p:sp>
+        <p:nvSpPr>
+          <p:cNvPr id="9" name="TextBox 8"/>
+          <p:cNvSpPr txBox="1"/>
+          <p:nvPr/>
+        </p:nvSpPr>
+        <p:spPr>
+          <a:xfrm>
+            <a:off x="822960" y="1737360"/>
+            <a:ext cx="5029200" cy="310896"/>
+          </a:xfrm>
+          <a:prstGeom prst="rect">
+            <a:avLst/>
+          </a:prstGeom>
+          <a:noFill/>
+        </p:spPr>
+        <p:txBody>
+          <a:bodyPr wrap="square" anchor="t" lIns="0" rIns="0" tIns="0" bIns="0">
+            <a:spAutoFit/>
+          </a:bodyPr>
+          <a:lstStyle/>
+          <a:p>
+            <a:pPr algn="l">
+              <a:lnSpc>
+                <a:spcPct val="125000"/>
+              </a:lnSpc>
+              <a:spcAft>
+                <a:spcPts val="800"/>
+              </a:spcAft>
+            </a:pPr>
+            <a:r>
+              <a:rPr sz="1500" b="1">
+                <a:solidFill>
+                  <a:srgbClr val="B45309"/>
+                </a:solidFill>
+                <a:latin typeface="微软雅黑"/>
+                <a:ea typeface="微软雅黑"/>
+              </a:rPr>
+              <a:t>AI 帮我们抓到的两个真实缺陷</a:t>
+            </a:r>
+          </a:p>
+        </p:txBody>
+      </p:sp>
+      <p:sp>
+        <p:nvSpPr>
+          <p:cNvPr id="10" name="TextBox 9"/>
+          <p:cNvSpPr txBox="1"/>
+          <p:nvPr/>
+        </p:nvSpPr>
+        <p:spPr>
+          <a:xfrm>
+            <a:off x="822960" y="2066543"/>
+            <a:ext cx="5029200" cy="1444751"/>
+          </a:xfrm>
+          <a:prstGeom prst="rect">
+            <a:avLst/>
+          </a:prstGeom>
+          <a:noFill/>
+        </p:spPr>
+        <p:txBody>
+          <a:bodyPr wrap="square" anchor="t" lIns="0" rIns="0" tIns="0" bIns="0">
+            <a:spAutoFit/>
+          </a:bodyPr>
+          <a:lstStyle/>
+          <a:p>
+            <a:pPr algn="l">
+              <a:lnSpc>
+                <a:spcPct val="125000"/>
+              </a:lnSpc>
+              <a:spcAft>
+                <a:spcPts val="600"/>
+              </a:spcAft>
+            </a:pPr>
+            <a:r>
+              <a:rPr sz="1200" b="0">
+                <a:solidFill>
+                  <a:srgbClr val="1F2937"/>
+                </a:solidFill>
+                <a:latin typeface="微软雅黑"/>
+                <a:ea typeface="微软雅黑"/>
+              </a:rPr>
+              <a:t>① 上下文丢失：模型只看到报告 7%~11% 内容（MAE 31.67 → 20.44）</a:t>
+            </a:r>
+          </a:p>
+          <a:p>
+            <a:pPr algn="l">
+              <a:lnSpc>
+                <a:spcPct val="125000"/>
+              </a:lnSpc>
+              <a:spcAft>
+                <a:spcPts val="600"/>
+              </a:spcAft>
+            </a:pPr>
+            <a:r>
+              <a:rPr sz="1200" b="0">
+                <a:solidFill>
+                  <a:srgbClr val="1F2937"/>
+                </a:solidFill>
+                <a:latin typeface="微软雅黑"/>
+                <a:ea typeface="微软雅黑"/>
+              </a:rPr>
+              <a:t>② 反馈生成失败：异常被 except 吞掉，查不到原因；最后靠另一项功能测试才炸出真凶——输出的 JSON 含未转义引号</a:t>
+            </a:r>
+          </a:p>
+          <a:p>
+            <a:pPr algn="l">
+              <a:lnSpc>
+                <a:spcPct val="125000"/>
+              </a:lnSpc>
+              <a:spcAft>
+                <a:spcPts val="600"/>
+              </a:spcAft>
+            </a:pPr>
+            <a:r>
+              <a:rPr sz="1200" b="0">
+                <a:solidFill>
+                  <a:srgbClr val="1F2937"/>
+                </a:solidFill>
+                <a:latin typeface="微软雅黑"/>
+                <a:ea typeface="微软雅黑"/>
+              </a:rPr>
+              <a:t>两篇排查记录都在仓库 docs/ 下，是当时写下的，不是事后美化</a:t>
+            </a:r>
+          </a:p>
+        </p:txBody>
+      </p:sp>
+      <p:sp>
+        <p:nvSpPr>
+          <p:cNvPr id="11" name="Rounded Rectangle 10"/>
+          <p:cNvSpPr/>
+          <p:nvPr/>
+        </p:nvSpPr>
+        <p:spPr>
+          <a:xfrm>
+            <a:off x="6236208" y="1572768"/>
+            <a:ext cx="5394960" cy="2103120"/>
+          </a:xfrm>
+          <a:prstGeom prst="roundRect">
+            <a:avLst>
+              <a:gd name="adj" fmla="val 8000"/>
+            </a:avLst>
+          </a:prstGeom>
+          <a:solidFill>
+            <a:srgbClr val="F3F4F6"/>
+          </a:solidFill>
+          <a:ln>
+            <a:noFill/>
+          </a:ln>
+          <a:effectLst/>
+        </p:spPr>
+        <p:style>
+          <a:lnRef idx="1">
+            <a:schemeClr val="accent1"/>
+          </a:lnRef>
+          <a:fillRef idx="3">
+            <a:schemeClr val="accent1"/>
+          </a:fillRef>
+          <a:effectRef idx="2">
+            <a:schemeClr val="accent1"/>
+          </a:effectRef>
+          <a:fontRef idx="minor">
+            <a:schemeClr val="lt1"/>
+          </a:fontRef>
+        </p:style>
+        <p:txBody>
+          <a:bodyPr rtlCol="0" anchor="ctr" wrap="square"/>
+          <a:lstStyle/>
+          <a:p>
+            <a:pPr algn="ctr"/>
+          </a:p>
+        </p:txBody>
+      </p:sp>
+      <p:sp>
+        <p:nvSpPr>
+          <p:cNvPr id="12" name="Rounded Rectangle 11"/>
+          <p:cNvSpPr/>
+          <p:nvPr/>
+        </p:nvSpPr>
+        <p:spPr>
+          <a:xfrm>
+            <a:off x="6236208" y="1572768"/>
+            <a:ext cx="50292" cy="2103120"/>
           </a:xfrm>
           <a:prstGeom prst="roundRect">
             <a:avLst>
@@ -10772,14 +11468,14 @@
       </p:sp>
       <p:sp>
         <p:nvSpPr>
-          <p:cNvPr id="17" name="TextBox 16"/>
+          <p:cNvPr id="13" name="TextBox 12"/>
           <p:cNvSpPr txBox="1"/>
           <p:nvPr/>
         </p:nvSpPr>
         <p:spPr>
           <a:xfrm>
-            <a:off x="822960" y="3986783"/>
-            <a:ext cx="5029200" cy="310896"/>
+            <a:off x="6492240" y="1737360"/>
+            <a:ext cx="4937760" cy="310896"/>
           </a:xfrm>
           <a:prstGeom prst="rect">
             <a:avLst/>
@@ -10808,21 +11504,21 @@
                 <a:latin typeface="微软雅黑"/>
                 <a:ea typeface="微软雅黑"/>
               </a:rPr>
-              <a:t>团队与分工（2 人，均为计算机科学与技术专业）</a:t>
-            </a:r>
-          </a:p>
-        </p:txBody>
-      </p:sp>
-      <p:sp>
-        <p:nvSpPr>
-          <p:cNvPr id="18" name="TextBox 17"/>
+              <a:t>AI 在工程里的位置</a:t>
+            </a:r>
+          </a:p>
+        </p:txBody>
+      </p:sp>
+      <p:sp>
+        <p:nvSpPr>
+          <p:cNvPr id="14" name="TextBox 13"/>
           <p:cNvSpPr txBox="1"/>
           <p:nvPr/>
         </p:nvSpPr>
         <p:spPr>
           <a:xfrm>
-            <a:off x="822960" y="4315968"/>
-            <a:ext cx="5029200" cy="1136650"/>
+            <a:off x="6492240" y="2066543"/>
+            <a:ext cx="4937760" cy="1444751"/>
           </a:xfrm>
           <a:prstGeom prst="rect">
             <a:avLst/>
@@ -10844,14 +11540,14 @@
               </a:spcAft>
             </a:pPr>
             <a:r>
-              <a:rPr sz="1100" b="0">
+              <a:rPr sz="1200" b="0">
                 <a:solidFill>
                   <a:srgbClr val="1F2937"/>
                 </a:solidFill>
                 <a:latin typeface="微软雅黑"/>
                 <a:ea typeface="微软雅黑"/>
               </a:rPr>
-              <a:t>黄宇科（主程）：代码 / 部署 / 版本管理 / 自评测工具</a:t>
+              <a:t>代码骨架、prompt 初稿、界面实现由 AI 协作产出</a:t>
             </a:r>
           </a:p>
           <a:p>
@@ -10864,14 +11560,14 @@
               </a:spcAft>
             </a:pPr>
             <a:r>
-              <a:rPr sz="1100" b="0">
+              <a:rPr sz="1200" b="0">
                 <a:solidFill>
                   <a:srgbClr val="1F2937"/>
                 </a:solidFill>
                 <a:latin typeface="微软雅黑"/>
                 <a:ea typeface="微软雅黑"/>
               </a:rPr>
-              <a:t>张镒川（产品与材料）：报告脱敏 / 评分点整理 / 独立人工打分 / 试用 / PPT / 视频</a:t>
+              <a:t>判定规则、评分点定义、gold set 打分由人完成</a:t>
             </a:r>
           </a:p>
           <a:p>
@@ -10884,28 +11580,28 @@
               </a:spcAft>
             </a:pPr>
             <a:r>
-              <a:rPr sz="1100" b="0">
+              <a:rPr sz="1200" b="0">
                 <a:solidFill>
                   <a:srgbClr val="1F2937"/>
                 </a:solidFill>
                 <a:latin typeface="微软雅黑"/>
                 <a:ea typeface="微软雅黑"/>
               </a:rPr>
-              <a:t>深圳大学计算机与软件学院 · 计算机科学与技术 · 2025 级 05 班</a:t>
-            </a:r>
-          </a:p>
-        </p:txBody>
-      </p:sp>
-      <p:sp>
-        <p:nvSpPr>
-          <p:cNvPr id="19" name="Rounded Rectangle 18"/>
+              <a:t>「不许吞异常」「不许放宽匹配规则」是我们给自己立的规矩</a:t>
+            </a:r>
+          </a:p>
+        </p:txBody>
+      </p:sp>
+      <p:sp>
+        <p:nvSpPr>
+          <p:cNvPr id="15" name="Rounded Rectangle 14"/>
           <p:cNvSpPr/>
           <p:nvPr/>
         </p:nvSpPr>
         <p:spPr>
           <a:xfrm>
-            <a:off x="6236208" y="3822191"/>
-            <a:ext cx="5394960" cy="1463040"/>
+            <a:off x="566928" y="3822191"/>
+            <a:ext cx="5486400" cy="1795018"/>
           </a:xfrm>
           <a:prstGeom prst="roundRect">
             <a:avLst>
@@ -10944,14 +11640,14 @@
       </p:sp>
       <p:sp>
         <p:nvSpPr>
-          <p:cNvPr id="20" name="Rounded Rectangle 19"/>
+          <p:cNvPr id="16" name="Rounded Rectangle 15"/>
           <p:cNvSpPr/>
           <p:nvPr/>
         </p:nvSpPr>
         <p:spPr>
           <a:xfrm>
-            <a:off x="6236208" y="3822191"/>
-            <a:ext cx="50292" cy="1463040"/>
+            <a:off x="566928" y="3822191"/>
+            <a:ext cx="50292" cy="1795018"/>
           </a:xfrm>
           <a:prstGeom prst="roundRect">
             <a:avLst>
@@ -10990,14 +11686,14 @@
       </p:sp>
       <p:sp>
         <p:nvSpPr>
-          <p:cNvPr id="21" name="TextBox 20"/>
+          <p:cNvPr id="17" name="TextBox 16"/>
           <p:cNvSpPr txBox="1"/>
           <p:nvPr/>
         </p:nvSpPr>
         <p:spPr>
           <a:xfrm>
-            <a:off x="6492240" y="3986783"/>
-            <a:ext cx="4937760" cy="310896"/>
+            <a:off x="822960" y="3986783"/>
+            <a:ext cx="5029200" cy="310896"/>
           </a:xfrm>
           <a:prstGeom prst="rect">
             <a:avLst/>
@@ -11026,21 +11722,21 @@
                 <a:latin typeface="微软雅黑"/>
                 <a:ea typeface="微软雅黑"/>
               </a:rPr>
-              <a:t>下一步</a:t>
-            </a:r>
-          </a:p>
-        </p:txBody>
-      </p:sp>
-      <p:sp>
-        <p:nvSpPr>
-          <p:cNvPr id="22" name="TextBox 21"/>
+              <a:t>团队与分工（2 人，均为计算机科学与技术专业）</a:t>
+            </a:r>
+          </a:p>
+        </p:txBody>
+      </p:sp>
+      <p:sp>
+        <p:nvSpPr>
+          <p:cNvPr id="18" name="TextBox 17"/>
           <p:cNvSpPr txBox="1"/>
           <p:nvPr/>
         </p:nvSpPr>
         <p:spPr>
           <a:xfrm>
-            <a:off x="6492240" y="4315968"/>
-            <a:ext cx="4937760" cy="804672"/>
+            <a:off x="822960" y="4315968"/>
+            <a:ext cx="5029200" cy="1136650"/>
           </a:xfrm>
           <a:prstGeom prst="rect">
             <a:avLst/>
@@ -11062,14 +11758,14 @@
               </a:spcAft>
             </a:pPr>
             <a:r>
-              <a:rPr sz="1150" b="0">
+              <a:rPr sz="1100" b="0">
                 <a:solidFill>
                   <a:srgbClr val="1F2937"/>
                 </a:solidFill>
                 <a:latin typeface="微软雅黑"/>
                 <a:ea typeface="微软雅黑"/>
               </a:rPr>
-              <a:t>把评分模板扩到更多课程与学科</a:t>
+              <a:t>黄宇科（主程）：代码 / 部署 / 版本管理 / 自评测工具</a:t>
             </a:r>
           </a:p>
           <a:p>
@@ -11082,14 +11778,14 @@
               </a:spcAft>
             </a:pPr>
             <a:r>
-              <a:rPr sz="1150" b="0">
+              <a:rPr sz="1100" b="0">
                 <a:solidFill>
                   <a:srgbClr val="1F2937"/>
                 </a:solidFill>
                 <a:latin typeface="微软雅黑"/>
                 <a:ea typeface="微软雅黑"/>
               </a:rPr>
-              <a:t>增加班级维度的批量视图与学情统计</a:t>
+              <a:t>张镒川（产品与材料）：报告脱敏 / 评分点整理 / 独立人工打分 / 试用 / PPT / 视频</a:t>
             </a:r>
           </a:p>
           <a:p>
@@ -11102,28 +11798,120 @@
               </a:spcAft>
             </a:pPr>
             <a:r>
-              <a:rPr sz="1150" b="0">
+              <a:rPr sz="1100" b="0">
                 <a:solidFill>
                   <a:srgbClr val="1F2937"/>
                 </a:solidFill>
                 <a:latin typeface="微软雅黑"/>
                 <a:ea typeface="微软雅黑"/>
               </a:rPr>
-              <a:t>把「重复评阅」做成常态化的稳定性看板</a:t>
-            </a:r>
-          </a:p>
-        </p:txBody>
-      </p:sp>
-      <p:sp>
-        <p:nvSpPr>
-          <p:cNvPr id="23" name="TextBox 22"/>
+              <a:t>深圳大学计算机与软件学院 · 计算机科学与技术 · 2025 级 05 班</a:t>
+            </a:r>
+          </a:p>
+        </p:txBody>
+      </p:sp>
+      <p:sp>
+        <p:nvSpPr>
+          <p:cNvPr id="19" name="Rounded Rectangle 18"/>
+          <p:cNvSpPr/>
+          <p:nvPr/>
+        </p:nvSpPr>
+        <p:spPr>
+          <a:xfrm>
+            <a:off x="6236208" y="3822191"/>
+            <a:ext cx="5394960" cy="1646428"/>
+          </a:xfrm>
+          <a:prstGeom prst="roundRect">
+            <a:avLst>
+              <a:gd name="adj" fmla="val 8000"/>
+            </a:avLst>
+          </a:prstGeom>
+          <a:solidFill>
+            <a:srgbClr val="F3F4F6"/>
+          </a:solidFill>
+          <a:ln>
+            <a:noFill/>
+          </a:ln>
+          <a:effectLst/>
+        </p:spPr>
+        <p:style>
+          <a:lnRef idx="1">
+            <a:schemeClr val="accent1"/>
+          </a:lnRef>
+          <a:fillRef idx="3">
+            <a:schemeClr val="accent1"/>
+          </a:fillRef>
+          <a:effectRef idx="2">
+            <a:schemeClr val="accent1"/>
+          </a:effectRef>
+          <a:fontRef idx="minor">
+            <a:schemeClr val="lt1"/>
+          </a:fontRef>
+        </p:style>
+        <p:txBody>
+          <a:bodyPr rtlCol="0" anchor="ctr" wrap="square"/>
+          <a:lstStyle/>
+          <a:p>
+            <a:pPr algn="ctr"/>
+          </a:p>
+        </p:txBody>
+      </p:sp>
+      <p:sp>
+        <p:nvSpPr>
+          <p:cNvPr id="20" name="Rounded Rectangle 19"/>
+          <p:cNvSpPr/>
+          <p:nvPr/>
+        </p:nvSpPr>
+        <p:spPr>
+          <a:xfrm>
+            <a:off x="6236208" y="3822191"/>
+            <a:ext cx="50292" cy="1646428"/>
+          </a:xfrm>
+          <a:prstGeom prst="roundRect">
+            <a:avLst>
+              <a:gd name="adj" fmla="val 50000"/>
+            </a:avLst>
+          </a:prstGeom>
+          <a:solidFill>
+            <a:srgbClr val="0F766E"/>
+          </a:solidFill>
+          <a:ln>
+            <a:noFill/>
+          </a:ln>
+          <a:effectLst/>
+        </p:spPr>
+        <p:style>
+          <a:lnRef idx="1">
+            <a:schemeClr val="accent1"/>
+          </a:lnRef>
+          <a:fillRef idx="3">
+            <a:schemeClr val="accent1"/>
+          </a:fillRef>
+          <a:effectRef idx="2">
+            <a:schemeClr val="accent1"/>
+          </a:effectRef>
+          <a:fontRef idx="minor">
+            <a:schemeClr val="lt1"/>
+          </a:fontRef>
+        </p:style>
+        <p:txBody>
+          <a:bodyPr rtlCol="0" anchor="ctr" wrap="square"/>
+          <a:lstStyle/>
+          <a:p>
+            <a:pPr algn="ctr"/>
+          </a:p>
+        </p:txBody>
+      </p:sp>
+      <p:sp>
+        <p:nvSpPr>
+          <p:cNvPr id="21" name="TextBox 20"/>
           <p:cNvSpPr txBox="1"/>
           <p:nvPr/>
         </p:nvSpPr>
         <p:spPr>
           <a:xfrm>
-            <a:off x="566928" y="5413248"/>
-            <a:ext cx="11064240" cy="822960"/>
+            <a:off x="6492240" y="3986783"/>
+            <a:ext cx="4937760" cy="310896"/>
           </a:xfrm>
           <a:prstGeom prst="rect">
             <a:avLst/>
@@ -11141,6 +11929,132 @@
                 <a:spcPct val="125000"/>
               </a:lnSpc>
               <a:spcAft>
+                <a:spcPts val="800"/>
+              </a:spcAft>
+            </a:pPr>
+            <a:r>
+              <a:rPr sz="1500" b="1">
+                <a:solidFill>
+                  <a:srgbClr val="1F2937"/>
+                </a:solidFill>
+                <a:latin typeface="微软雅黑"/>
+                <a:ea typeface="微软雅黑"/>
+              </a:rPr>
+              <a:t>下一步</a:t>
+            </a:r>
+          </a:p>
+        </p:txBody>
+      </p:sp>
+      <p:sp>
+        <p:nvSpPr>
+          <p:cNvPr id="22" name="TextBox 21"/>
+          <p:cNvSpPr txBox="1"/>
+          <p:nvPr/>
+        </p:nvSpPr>
+        <p:spPr>
+          <a:xfrm>
+            <a:off x="6492240" y="4315968"/>
+            <a:ext cx="4937760" cy="988060"/>
+          </a:xfrm>
+          <a:prstGeom prst="rect">
+            <a:avLst/>
+          </a:prstGeom>
+          <a:noFill/>
+        </p:spPr>
+        <p:txBody>
+          <a:bodyPr wrap="square" anchor="t" lIns="0" rIns="0" tIns="0" bIns="0">
+            <a:spAutoFit/>
+          </a:bodyPr>
+          <a:lstStyle/>
+          <a:p>
+            <a:pPr algn="l">
+              <a:lnSpc>
+                <a:spcPct val="125000"/>
+              </a:lnSpc>
+              <a:spcAft>
+                <a:spcPts val="600"/>
+              </a:spcAft>
+            </a:pPr>
+            <a:r>
+              <a:rPr sz="1150" b="0">
+                <a:solidFill>
+                  <a:srgbClr val="1F2937"/>
+                </a:solidFill>
+                <a:latin typeface="微软雅黑"/>
+                <a:ea typeface="微软雅黑"/>
+              </a:rPr>
+              <a:t>把评分模板扩到更多课程与学科</a:t>
+            </a:r>
+          </a:p>
+          <a:p>
+            <a:pPr algn="l">
+              <a:lnSpc>
+                <a:spcPct val="125000"/>
+              </a:lnSpc>
+              <a:spcAft>
+                <a:spcPts val="600"/>
+              </a:spcAft>
+            </a:pPr>
+            <a:r>
+              <a:rPr sz="1150" b="0">
+                <a:solidFill>
+                  <a:srgbClr val="1F2937"/>
+                </a:solidFill>
+                <a:latin typeface="微软雅黑"/>
+                <a:ea typeface="微软雅黑"/>
+              </a:rPr>
+              <a:t>增加班级维度的批量视图与学情统计</a:t>
+            </a:r>
+          </a:p>
+          <a:p>
+            <a:pPr algn="l">
+              <a:lnSpc>
+                <a:spcPct val="125000"/>
+              </a:lnSpc>
+              <a:spcAft>
+                <a:spcPts val="600"/>
+              </a:spcAft>
+            </a:pPr>
+            <a:r>
+              <a:rPr sz="1150" b="0">
+                <a:solidFill>
+                  <a:srgbClr val="1F2937"/>
+                </a:solidFill>
+                <a:latin typeface="微软雅黑"/>
+                <a:ea typeface="微软雅黑"/>
+              </a:rPr>
+              <a:t>把多模态 OCR 扩到 DOCX 内嵌图片，并做一次读图准确率的人工抽样评测</a:t>
+            </a:r>
+          </a:p>
+        </p:txBody>
+      </p:sp>
+      <p:sp>
+        <p:nvSpPr>
+          <p:cNvPr id="23" name="TextBox 22"/>
+          <p:cNvSpPr txBox="1"/>
+          <p:nvPr/>
+        </p:nvSpPr>
+        <p:spPr>
+          <a:xfrm>
+            <a:off x="566928" y="5413248"/>
+            <a:ext cx="11064240" cy="822960"/>
+          </a:xfrm>
+          <a:prstGeom prst="rect">
+            <a:avLst/>
+          </a:prstGeom>
+          <a:noFill/>
+        </p:spPr>
+        <p:txBody>
+          <a:bodyPr wrap="square" anchor="t" lIns="0" rIns="0" tIns="0" bIns="0">
+            <a:spAutoFit/>
+          </a:bodyPr>
+          <a:lstStyle/>
+          <a:p>
+            <a:pPr algn="l">
+              <a:lnSpc>
+                <a:spcPct val="125000"/>
+              </a:lnSpc>
+              <a:spcAft>
                 <a:spcPts val="400"/>
               </a:spcAft>
             </a:pPr>
@@ -11172,7 +12086,7 @@
                 <a:latin typeface="微软雅黑"/>
                 <a:ea typeface="微软雅黑"/>
               </a:rPr>
-              <a:t>提交前提示：MAE / 误差占比 / 可溯源率以最新一次 benchmark 为准，若与本次不一致请以新数字更新本页。</a:t>
+              <a:t>提交前提示：MAE / 误差占比 / 可溯源率以最新一次 benchmark 为准，若与本次不一致请以新数字更新本页（本页与 README、作品主页读的是同一组值，三处必须一致 —— 评委交叉核对时对不上就是硬伤）。</a:t>
             </a:r>
           </a:p>
         </p:txBody>

</xml_diff>